<commit_message>
Prepare PatchReceipt hackathon submission
</commit_message>
<xml_diff>
--- a/docs/PRESENTATION.pptx
+++ b/docs/PRESENTATION.pptx
@@ -2,19 +2,19 @@
 <file path=ppt/presentation.xml><?xml version="1.0" encoding="utf-8"?>
 <p:presentation xmlns:p="http://schemas.openxmlformats.org/presentationml/2006/main">
   <p:sldMasterIdLst>
-    <p:sldMasterId xmlns:r="http://schemas.openxmlformats.org/officeDocument/2006/relationships" id="2147483648" r:id="R330cad03351a4e27"/>
+    <p:sldMasterId xmlns:r="http://schemas.openxmlformats.org/officeDocument/2006/relationships" id="2147483648" r:id="Rce36551bece44748"/>
   </p:sldMasterIdLst>
   <p:notesMasterIdLst>
-    <p:notesMasterId xmlns:r="http://schemas.openxmlformats.org/officeDocument/2006/relationships" r:id="R4f686b629bb24571"/>
+    <p:notesMasterId xmlns:r="http://schemas.openxmlformats.org/officeDocument/2006/relationships" r:id="Rc07faac1e68c4dd5"/>
   </p:notesMasterIdLst>
   <p:sldIdLst>
-    <p:sldId xmlns:r="http://schemas.openxmlformats.org/officeDocument/2006/relationships" id="256" r:id="Rebc4521942a4471e"/>
-    <p:sldId xmlns:r="http://schemas.openxmlformats.org/officeDocument/2006/relationships" id="257" r:id="Rfa1d55c585894423"/>
-    <p:sldId xmlns:r="http://schemas.openxmlformats.org/officeDocument/2006/relationships" id="258" r:id="Rfb669c00a7dd4af2"/>
-    <p:sldId xmlns:r="http://schemas.openxmlformats.org/officeDocument/2006/relationships" id="259" r:id="Ra0bde153fee34a1d"/>
-    <p:sldId xmlns:r="http://schemas.openxmlformats.org/officeDocument/2006/relationships" id="260" r:id="R9e9e0cdc0ad74550"/>
-    <p:sldId xmlns:r="http://schemas.openxmlformats.org/officeDocument/2006/relationships" id="261" r:id="R1796cd091e8b441f"/>
-    <p:sldId xmlns:r="http://schemas.openxmlformats.org/officeDocument/2006/relationships" id="262" r:id="R1d8b16cad42a4b05"/>
+    <p:sldId xmlns:r="http://schemas.openxmlformats.org/officeDocument/2006/relationships" id="256" r:id="R79b12778a2f449e5"/>
+    <p:sldId xmlns:r="http://schemas.openxmlformats.org/officeDocument/2006/relationships" id="257" r:id="R5cd5764d98b44192"/>
+    <p:sldId xmlns:r="http://schemas.openxmlformats.org/officeDocument/2006/relationships" id="258" r:id="Ra524a658cdba4f38"/>
+    <p:sldId xmlns:r="http://schemas.openxmlformats.org/officeDocument/2006/relationships" id="259" r:id="Rf5aade55fbbe4842"/>
+    <p:sldId xmlns:r="http://schemas.openxmlformats.org/officeDocument/2006/relationships" id="260" r:id="R93d7d2ef41864a8c"/>
+    <p:sldId xmlns:r="http://schemas.openxmlformats.org/officeDocument/2006/relationships" id="261" r:id="Rb2b5ff8696854559"/>
+    <p:sldId xmlns:r="http://schemas.openxmlformats.org/officeDocument/2006/relationships" id="262" r:id="Rbf0948049af142b3"/>
   </p:sldIdLst>
   <p:sldSz cx="12192000" cy="6858000"/>
   <p:notesSz cx="6858000" cy="9144000"/>
@@ -878,7 +878,7 @@
           <a:lstStyle xmlns:a="http://schemas.openxmlformats.org/drawingml/2006/main"/>
           <a:p xmlns:a="http://schemas.openxmlformats.org/drawingml/2006/main">
             <a:r>
-              <a:t>These figures are generated from the current local build. The 27-second figure is the observed robust public-candidate run; deployed p95 remains pending until the service is hosted.</a:t>
+              <a:t>These figures come from the frozen Java 21 evaluation. The 25.9-second figure is the final packaged public-candidate run (25.943 seconds measured); deployed p95 remains pending until the service is hosted.</a:t>
             </a:r>
           </a:p>
           <a:p xmlns:a="http://schemas.openxmlformats.org/drawingml/2006/main">
@@ -898,7 +898,7 @@
           </a:p>
           <a:p xmlns:a="http://schemas.openxmlformats.org/drawingml/2006/main">
             <a:r>
-              <a:t>- Local evidence: target/evaluation-receipts/summary.txt</a:t>
+              <a:t>- Local evidence: docs/evidence/evaluation-summary.json</a:t>
             </a:r>
           </a:p>
           <a:p xmlns:a="http://schemas.openxmlformats.org/drawingml/2006/main">
@@ -1066,7 +1066,7 @@
   </p:cSld>
   <p:clrMap bg1="lt1" tx1="dk1" bg2="lt2" tx2="dk2" accent1="accent1" accent2="accent2" accent3="accent3" accent4="accent4" accent5="accent5" accent6="accent6" hlink="hlink" folHlink="folHlink"/>
   <p:sldLayoutIdLst>
-    <p:sldLayoutId xmlns:r="http://schemas.openxmlformats.org/officeDocument/2006/relationships" id="2147483649" r:id="R04cdc3eb27924819"/>
+    <p:sldLayoutId xmlns:r="http://schemas.openxmlformats.org/officeDocument/2006/relationships" id="2147483649" r:id="Rd1e7e43962c84375"/>
   </p:sldLayoutIdLst>
   <p:txStyles>
     <p:titleStyle>
@@ -1721,7 +1721,18 @@
                 <a:ea typeface="Aptos"/>
                 <a:cs typeface="Aptos"/>
               </a:rPr>
-              <a:t>Codex writes the patch.
+              <a:t>AI writes the patch.</a:t>
+            </a:r>
+            <a:r>
+              <a:rPr sz="2100" b="0">
+                <a:solidFill>
+                  <a:srgbClr val="121510"/>
+                </a:solidFill>
+                <a:latin typeface="Aptos"/>
+                <a:ea typeface="Aptos"/>
+                <a:cs typeface="Aptos"/>
+              </a:rPr>
+              <a:t>
 PatchReceipt proves whether it deserves to ship.</a:t>
             </a:r>
           </a:p>
@@ -1876,6 +1887,7 @@
           <a:lstStyle xmlns:a="http://schemas.openxmlformats.org/drawingml/2006/main"/>
           <a:p xmlns:a="http://schemas.openxmlformats.org/drawingml/2006/main">
             <a:pPr algn="r">
+              <a:buNone/>
               <a:defRPr sz="1000">
                 <a:solidFill>
                   <a:srgbClr val="000000"/>
@@ -2578,6 +2590,7 @@
           <a:lstStyle xmlns:a="http://schemas.openxmlformats.org/drawingml/2006/main"/>
           <a:p xmlns:a="http://schemas.openxmlformats.org/drawingml/2006/main">
             <a:pPr algn="r">
+              <a:buNone/>
               <a:defRPr sz="1000">
                 <a:solidFill>
                   <a:srgbClr val="000000"/>
@@ -2871,7 +2884,7 @@
                 <a:ea typeface="Aptos"/>
                 <a:cs typeface="Aptos"/>
               </a:rPr>
-              <a:t>9/9 edge cases, 4/4 mutants, clean declared scope.</a:t>
+              <a:t>9/9 edge cases, 5/5 mutants, clean observed scope.</a:t>
             </a:r>
           </a:p>
         </p:txBody>
@@ -3628,6 +3641,7 @@
           <a:lstStyle xmlns:a="http://schemas.openxmlformats.org/drawingml/2006/main"/>
           <a:p xmlns:a="http://schemas.openxmlformats.org/drawingml/2006/main">
             <a:pPr algn="r">
+              <a:buNone/>
               <a:defRPr sz="1000">
                 <a:solidFill>
                   <a:srgbClr val="000000"/>
@@ -3702,7 +3716,7 @@
       </p:sp>
       <p:cxnSp>
         <p:nvCxnSpPr>
-          <p:cNvPr id="18" name="Google-Shape-2259-p159-4"/>
+          <p:cNvPr id="45" name="Google-Shape-2259-p159-4"/>
           <p:cNvCxnSpPr/>
           <p:nvPr/>
         </p:nvCxnSpPr>
@@ -4223,7 +4237,18 @@
                 <a:ea typeface="Aptos"/>
                 <a:cs typeface="Aptos"/>
               </a:rPr>
-              <a:t>Scope policy + hashes
+              <a:t>Observed scope + hashes</a:t>
+            </a:r>
+            <a:r>
+              <a:rPr sz="1500" b="0">
+                <a:solidFill>
+                  <a:srgbClr val="5B6256"/>
+                </a:solidFill>
+                <a:latin typeface="Aptos"/>
+                <a:ea typeface="Aptos"/>
+                <a:cs typeface="Aptos"/>
+              </a:rPr>
+              <a:t>
 HTML · Markdown · JSON</a:t>
             </a:r>
           </a:p>
@@ -4385,6 +4410,7 @@
           <a:lstStyle xmlns:a="http://schemas.openxmlformats.org/drawingml/2006/main"/>
           <a:p xmlns:a="http://schemas.openxmlformats.org/drawingml/2006/main">
             <a:pPr algn="r">
+              <a:buNone/>
               <a:defRPr sz="1000">
                 <a:solidFill>
                   <a:srgbClr val="000000"/>
@@ -4828,6 +4854,7 @@
           <a:lstStyle xmlns:a="http://schemas.openxmlformats.org/drawingml/2006/main"/>
           <a:p xmlns:a="http://schemas.openxmlformats.org/drawingml/2006/main">
             <a:pPr algn="ctr">
+              <a:buNone/>
               <a:defRPr sz="975" b="1">
                 <a:solidFill>
                   <a:srgbClr val="121510"/>
@@ -4989,6 +5016,7 @@
           <a:lstStyle xmlns:a="http://schemas.openxmlformats.org/drawingml/2006/main"/>
           <a:p xmlns:a="http://schemas.openxmlformats.org/drawingml/2006/main">
             <a:pPr algn="r">
+              <a:buNone/>
               <a:defRPr sz="1000">
                 <a:solidFill>
                   <a:srgbClr val="000000"/>
@@ -5170,7 +5198,7 @@
                 <a:ea typeface="Aptos"/>
                 <a:cs typeface="Aptos"/>
               </a:rPr>
-              <a:t>robust local run</a:t>
+              <a:t>final packaged run</a:t>
             </a:r>
           </a:p>
         </p:txBody>
@@ -5398,7 +5426,7 @@
                 <a:ea typeface="Aptos"/>
                 <a:cs typeface="Aptos"/>
               </a:rPr>
-              <a:t>27 s</a:t>
+              <a:t>25.9 s</a:t>
             </a:r>
           </a:p>
         </p:txBody>
@@ -5526,6 +5554,7 @@
           <a:lstStyle xmlns:a="http://schemas.openxmlformats.org/drawingml/2006/main"/>
           <a:p xmlns:a="http://schemas.openxmlformats.org/drawingml/2006/main">
             <a:pPr algn="ctr">
+              <a:buNone/>
               <a:defRPr sz="975" b="1">
                 <a:solidFill>
                   <a:srgbClr val="121510"/>

</xml_diff>